<commit_message>
WIP: cell segmentation exploration, reports, diagnostic outputs
Dirty checkpoint for handoff — uncommitted outputs and in-progress work:
- reports/260213_all_wells_all_days/ + reproduced/ (CSV + figures)
- reports/260213_pilot_9day/ and pilot_reproduced/ (methods draft, PI README)
- outputs/plots/ (drift, segmentation, registration diagnostics)
- ALIGNMENT_COMPLETION_PLAN.md (step-by-step for feat/alignment-method-comparison PR)
- notebooks/tile_stitching_demo.ipynb + .py
- scripts/build_github_pages_dashboard.py (updated)

Co-Authored-By: Claude Sonnet 4.6 (1M context) <noreply@anthropic.com>
</commit_message>
<xml_diff>
--- a/outputs/tmem106b_neuron_alignment_meeting_deck.pptx
+++ b/outputs/tmem106b_neuron_alignment_meeting_deck.pptx
@@ -6707,7 +6707,7 @@
       </p:sp>
       <p:pic>
         <p:nvPicPr>
-          <p:cNvPr id="15" name="Picture 14" descr="E05_vs_F05_single_neuron_mcherry.gif"/>
+          <p:cNvPr id="15" name="Picture 14" descr="single_neuron_mcherry_metric_over_time.png"/>
           <p:cNvPicPr>
             <a:picLocks noChangeAspect="1"/>
           </p:cNvPicPr>
@@ -6721,30 +6721,6 @@
         </p:blipFill>
         <p:spPr>
           <a:xfrm>
-            <a:off x="937259" y="6903720"/>
-            <a:ext cx="2286000" cy="1143000"/>
-          </a:xfrm>
-          <a:prstGeom prst="rect">
-            <a:avLst/>
-          </a:prstGeom>
-        </p:spPr>
-      </p:pic>
-      <p:pic>
-        <p:nvPicPr>
-          <p:cNvPr id="16" name="Picture 15" descr="single_neuron_mcherry_metric_over_time.png"/>
-          <p:cNvPicPr>
-            <a:picLocks noChangeAspect="1"/>
-          </p:cNvPicPr>
-          <p:nvPr/>
-        </p:nvPicPr>
-        <p:blipFill>
-          <a:blip r:embed="rId4"/>
-          <a:stretch>
-            <a:fillRect/>
-          </a:stretch>
-        </p:blipFill>
-        <p:spPr>
-          <a:xfrm>
             <a:off x="3558000" y="6629400"/>
             <a:ext cx="1982279" cy="1417320"/>
           </a:xfrm>
@@ -6755,7 +6731,7 @@
       </p:pic>
       <p:sp>
         <p:nvSpPr>
-          <p:cNvPr id="17" name="TextBox 16"/>
+          <p:cNvPr id="16" name="TextBox 15"/>
           <p:cNvSpPr txBox="1"/>
           <p:nvPr/>
         </p:nvSpPr>

</xml_diff>